<commit_message>
add picture of Dini
</commit_message>
<xml_diff>
--- a/2020-05-30.pptx
+++ b/2020-05-30.pptx
@@ -29,6 +29,8 @@
     <p:sldId id="277" r:id="rId23"/>
     <p:sldId id="278" r:id="rId24"/>
     <p:sldId id="279" r:id="rId25"/>
+    <p:sldId id="280" r:id="rId26"/>
+    <p:sldId id="281" r:id="rId27"/>
   </p:sldIdLst>
   <p:sldSz cx="9144000" cy="6858000" type="screen4x3"/>
   <p:notesSz cx="6858000" cy="9144000"/>
@@ -3307,6 +3309,132 @@
           <a:chExt cx="0" cy="0"/>
         </a:xfrm>
       </p:grpSpPr>
+      <p:sp>
+        <p:nvSpPr>
+          <p:cNvPr id="2" name="Title 1"/>
+          <p:cNvSpPr>
+            <a:spLocks noGrp="1"/>
+          </p:cNvSpPr>
+          <p:nvPr>
+            <p:ph type="title"/>
+          </p:nvPr>
+        </p:nvSpPr>
+        <p:spPr/>
+        <p:txBody>
+          <a:bodyPr/>
+          <a:lstStyle/>
+          <a:p>
+            <a:pPr lvl="0" marL="0" indent="0">
+              <a:buNone/>
+            </a:pPr>
+            <a:r>
+              <a:rPr/>
+              <a:t>Intégration</a:t>
+            </a:r>
+            <a:r>
+              <a:rPr/>
+              <a:t> </a:t>
+            </a:r>
+            <a:r>
+              <a:rPr/>
+              <a:t>à</a:t>
+            </a:r>
+            <a:r>
+              <a:rPr/>
+              <a:t> </a:t>
+            </a:r>
+            <a:r>
+              <a:rPr/>
+              <a:t>l’Inspé</a:t>
+            </a:r>
+          </a:p>
+        </p:txBody>
+      </p:sp>
+      <p:sp>
+        <p:nvSpPr>
+          <p:cNvPr id="3" name="Content Placeholder 2"/>
+          <p:cNvSpPr>
+            <a:spLocks noGrp="1"/>
+          </p:cNvSpPr>
+          <p:nvPr>
+            <p:ph idx="1"/>
+          </p:nvPr>
+        </p:nvSpPr>
+        <p:spPr/>
+        <p:txBody>
+          <a:bodyPr/>
+          <a:lstStyle/>
+          <a:p>
+            <a:pPr lvl="0" marL="0" indent="0">
+              <a:spcBef>
+                <a:spcPts val="3000"/>
+              </a:spcBef>
+              <a:buNone/>
+            </a:pPr>
+            <a:r>
+              <a:rPr b="1"/>
+              <a:t>Motivée par les questions éducatives</a:t>
+            </a:r>
+          </a:p>
+          <a:p>
+            <a:pPr lvl="1"/>
+            <a:r>
+              <a:rPr/>
+              <a:t>suivi deux MOOC sur l’éducation</a:t>
+            </a:r>
+          </a:p>
+          <a:p>
+            <a:pPr lvl="2"/>
+            <a:r>
+              <a:rPr/>
+              <a:t>eFan Maths session 2 (ESPÉ de Lyon et autres partenaires)</a:t>
+            </a:r>
+          </a:p>
+          <a:p>
+            <a:pPr lvl="3"/>
+            <a:r>
+              <a:rPr/>
+              <a:t>projet «Objets mathématiques imprimés en 3D»</a:t>
+            </a:r>
+          </a:p>
+          <a:p>
+            <a:pPr lvl="2"/>
+            <a:r>
+              <a:rPr/>
+              <a:t>Design and Development of Educational Technology (MIT)</a:t>
+            </a:r>
+          </a:p>
+          <a:p>
+            <a:pPr lvl="3"/>
+            <a:r>
+              <a:rPr/>
+              <a:t>projet «Plagiarism prevention»</a:t>
+            </a:r>
+          </a:p>
+        </p:txBody>
+      </p:sp>
+    </p:spTree>
+  </p:cSld>
+</p:sld>
+</file>
+
+<file path=ppt/slides/slide11.xml><?xml version="1.0" encoding="utf-8"?>
+<p:sld xmlns:a="http://schemas.openxmlformats.org/drawingml/2006/main" xmlns:r="http://schemas.openxmlformats.org/officeDocument/2006/relationships" xmlns:p="http://schemas.openxmlformats.org/presentationml/2006/main">
+  <p:cSld>
+    <p:spTree>
+      <p:nvGrpSpPr>
+        <p:cNvPr id="1" name=""/>
+        <p:cNvGrpSpPr/>
+        <p:nvPr/>
+      </p:nvGrpSpPr>
+      <p:grpSpPr>
+        <a:xfrm>
+          <a:off x="0" y="0"/>
+          <a:ext cx="0" cy="0"/>
+          <a:chOff x="0" y="0"/>
+          <a:chExt cx="0" cy="0"/>
+        </a:xfrm>
+      </p:grpSpPr>
       <p:pic>
         <p:nvPicPr>
           <p:cNvPr descr="img/reussite-fun-edx.png" id="0" name="Picture 1"/>
@@ -3342,7 +3470,7 @@
 </p:sld>
 </file>
 
-<file path=ppt/slides/slide11.xml><?xml version="1.0" encoding="utf-8"?>
+<file path=ppt/slides/slide12.xml><?xml version="1.0" encoding="utf-8"?>
 <p:sld xmlns:a="http://schemas.openxmlformats.org/drawingml/2006/main" xmlns:r="http://schemas.openxmlformats.org/officeDocument/2006/relationships" xmlns:p="http://schemas.openxmlformats.org/presentationml/2006/main">
   <p:cSld>
     <p:spTree>
@@ -3415,7 +3543,7 @@
 </p:sld>
 </file>
 
-<file path=ppt/slides/slide12.xml><?xml version="1.0" encoding="utf-8"?>
+<file path=ppt/slides/slide13.xml><?xml version="1.0" encoding="utf-8"?>
 <p:sld xmlns:a="http://schemas.openxmlformats.org/drawingml/2006/main" xmlns:r="http://schemas.openxmlformats.org/officeDocument/2006/relationships" xmlns:p="http://schemas.openxmlformats.org/presentationml/2006/main">
   <p:cSld>
     <p:spTree>
@@ -3581,7 +3709,7 @@
 </p:sld>
 </file>
 
-<file path=ppt/slides/slide13.xml><?xml version="1.0" encoding="utf-8"?>
+<file path=ppt/slides/slide14.xml><?xml version="1.0" encoding="utf-8"?>
 <p:sld xmlns:a="http://schemas.openxmlformats.org/drawingml/2006/main" xmlns:r="http://schemas.openxmlformats.org/officeDocument/2006/relationships" xmlns:p="http://schemas.openxmlformats.org/presentationml/2006/main">
   <p:cSld>
     <p:spTree>
@@ -3730,18 +3858,6 @@
                   <a:t>former à un enseignement des mathématiques qui aident à comprendre le monde</a:t>
                 </a:r>
               </a:p>
-              <a:p>
-                <a:pPr lvl="0" marL="0" indent="0">
-                  <a:spcBef>
-                    <a:spcPts val="3000"/>
-                  </a:spcBef>
-                  <a:buNone/>
-                </a:pPr>
-                <a:r>
-                  <a:rPr b="1"/>
-                  <a:t>Mise en relation entre mon parcours et la formation des enseignants</a:t>
-                </a:r>
-              </a:p>
             </p:txBody>
           </p:sp>
         </mc:Choice>
@@ -3751,7 +3867,57 @@
 </p:sld>
 </file>
 
-<file path=ppt/slides/slide14.xml><?xml version="1.0" encoding="utf-8"?>
+<file path=ppt/slides/slide15.xml><?xml version="1.0" encoding="utf-8"?>
+<p:sld xmlns:a="http://schemas.openxmlformats.org/drawingml/2006/main" xmlns:r="http://schemas.openxmlformats.org/officeDocument/2006/relationships" xmlns:p="http://schemas.openxmlformats.org/presentationml/2006/main">
+  <p:cSld>
+    <p:spTree>
+      <p:nvGrpSpPr>
+        <p:cNvPr id="1" name=""/>
+        <p:cNvGrpSpPr/>
+        <p:nvPr/>
+      </p:nvGrpSpPr>
+      <p:grpSpPr>
+        <a:xfrm>
+          <a:off x="0" y="0"/>
+          <a:ext cx="0" cy="0"/>
+          <a:chOff x="0" y="0"/>
+          <a:chExt cx="0" cy="0"/>
+        </a:xfrm>
+      </p:grpSpPr>
+      <p:sp>
+        <p:nvSpPr>
+          <p:cNvPr id="3" name="Content Placeholder 2"/>
+          <p:cNvSpPr>
+            <a:spLocks noGrp="1"/>
+          </p:cNvSpPr>
+          <p:nvPr>
+            <p:ph idx="1"/>
+          </p:nvPr>
+        </p:nvSpPr>
+        <p:spPr/>
+        <p:txBody>
+          <a:bodyPr/>
+          <a:lstStyle/>
+          <a:p>
+            <a:pPr lvl="0" marL="0" indent="0">
+              <a:spcBef>
+                <a:spcPts val="3000"/>
+              </a:spcBef>
+              <a:buNone/>
+            </a:pPr>
+            <a:r>
+              <a:rPr b="1"/>
+              <a:t>Mise en relation entre mon parcours et la formation des enseignants</a:t>
+            </a:r>
+          </a:p>
+        </p:txBody>
+      </p:sp>
+    </p:spTree>
+  </p:cSld>
+</p:sld>
+</file>
+
+<file path=ppt/slides/slide16.xml><?xml version="1.0" encoding="utf-8"?>
 <p:sld xmlns:a="http://schemas.openxmlformats.org/drawingml/2006/main" xmlns:r="http://schemas.openxmlformats.org/officeDocument/2006/relationships" xmlns:p="http://schemas.openxmlformats.org/presentationml/2006/main">
   <p:cSld>
     <p:spTree>
@@ -4317,110 +4483,6 @@
 </p:sld>
 </file>
 
-<file path=ppt/slides/slide15.xml><?xml version="1.0" encoding="utf-8"?>
-<p:sld xmlns:a="http://schemas.openxmlformats.org/drawingml/2006/main" xmlns:r="http://schemas.openxmlformats.org/officeDocument/2006/relationships" xmlns:p="http://schemas.openxmlformats.org/presentationml/2006/main">
-  <p:cSld>
-    <p:spTree>
-      <p:nvGrpSpPr>
-        <p:cNvPr id="1" name=""/>
-        <p:cNvGrpSpPr/>
-        <p:nvPr/>
-      </p:nvGrpSpPr>
-      <p:grpSpPr>
-        <a:xfrm>
-          <a:off x="0" y="0"/>
-          <a:ext cx="0" cy="0"/>
-          <a:chOff x="0" y="0"/>
-          <a:chExt cx="0" cy="0"/>
-        </a:xfrm>
-      </p:grpSpPr>
-      <p:sp>
-        <p:nvSpPr>
-          <p:cNvPr id="2" name="Title 1"/>
-          <p:cNvSpPr>
-            <a:spLocks noGrp="1"/>
-          </p:cNvSpPr>
-          <p:nvPr>
-            <p:ph type="title"/>
-          </p:nvPr>
-        </p:nvSpPr>
-        <p:spPr/>
-        <p:txBody>
-          <a:bodyPr/>
-          <a:lstStyle/>
-          <a:p>
-            <a:pPr lvl="0" marL="0" indent="0">
-              <a:buNone/>
-            </a:pPr>
-            <a:r>
-              <a:rPr/>
-              <a:t>Propositions</a:t>
-            </a:r>
-            <a:r>
-              <a:rPr/>
-              <a:t> </a:t>
-            </a:r>
-            <a:r>
-              <a:rPr/>
-              <a:t>pour</a:t>
-            </a:r>
-            <a:r>
-              <a:rPr/>
-              <a:t> </a:t>
-            </a:r>
-            <a:r>
-              <a:rPr/>
-              <a:t>SFERE-Provence</a:t>
-            </a:r>
-          </a:p>
-        </p:txBody>
-      </p:sp>
-      <p:sp>
-        <p:nvSpPr>
-          <p:cNvPr id="3" name="Content Placeholder 2"/>
-          <p:cNvSpPr>
-            <a:spLocks noGrp="1"/>
-          </p:cNvSpPr>
-          <p:nvPr>
-            <p:ph idx="1"/>
-          </p:nvPr>
-        </p:nvSpPr>
-        <p:spPr/>
-        <p:txBody>
-          <a:bodyPr/>
-          <a:lstStyle/>
-          <a:p>
-            <a:pPr lvl="0" marL="0" indent="0">
-              <a:spcBef>
-                <a:spcPts val="3000"/>
-              </a:spcBef>
-              <a:buNone/>
-            </a:pPr>
-            <a:r>
-              <a:rPr b="1"/>
-              <a:t>Projets de recherche</a:t>
-            </a:r>
-          </a:p>
-          <a:p>
-            <a:pPr lvl="0" marL="0" indent="0">
-              <a:buNone/>
-            </a:pPr>
-            <a:r>
-              <a:rPr/>
-              <a:t>Les projets de recherche déjà présentés:</a:t>
-            </a:r>
-          </a:p>
-        </p:txBody>
-      </p:sp>
-    </p:spTree>
-  </p:cSld>
-</p:sld>
-</file>
-
-<file path=ppt/slides/slide16.xml><?xml version="1.0" encoding="UTF-8"?>
-<p:sld xmlns:a="http://schemas.openxmlformats.org/drawingml/2006/main" xmlns:r="http://schemas.openxmlformats.org/officeDocument/2006/relationships" xmlns:p="http://schemas.openxmlformats.org/presentationml/2006/main"><p:cSld><p:spTree><p:nvGrpSpPr><p:cNvPr id="1" name="" /><p:cNvGrpSpPr /><p:nvPr /></p:nvGrpSpPr><p:grpSpPr><a:xfrm><a:off x="0" y="0" /><a:ext cx="0" cy="0" /><a:chOff x="0" y="0" /><a:chExt cx="0" cy="0" /></a:xfrm></p:grpSpPr><p:graphicFrame><p:nvGraphicFramePr><p:cNvPr id="6" name="Content Placeholder 5" /><p:cNvGraphicFramePr><a:graphicFrameLocks noGrp="1" /></p:cNvGraphicFramePr><p:nvPr><p:ph idx="1" /></p:nvPr></p:nvGraphicFramePr><p:xfrm><a:off x="457200" y="1600200" /><a:ext cx="8229600" cy="4521200" /></p:xfrm><a:graphic><a:graphicData uri="http://schemas.openxmlformats.org/drawingml/2006/table"><a:tbl><a:tblPr firstRow="1" bandRow="1"><a:tableStyleId>{5C22544A-7EE6-4342-B048-85BDC9FD1C3A}</a:tableStyleId></a:tblPr><a:tblGrid><a:gridCol w="4114800" /><a:gridCol w="4114800" /></a:tblGrid><a:tr h="0"><a:tc><a:txBody><a:bodyPr /><a:lstStyle /><a:p><a:pPr lvl="0" marL="0" indent="0" algn="l"><a:buNone /></a:pPr><a:r><a:rPr /><a:t>Primaire</a:t></a:r></a:p></a:txBody></a:tc><a:tc><a:txBody><a:bodyPr /><a:lstStyle /><a:p><a:pPr lvl="0" marL="0" indent="0" algn="l"><a:buNone /></a:pPr><a:r><a:rPr /><a:t>Nombres</a:t></a:r><a:r><a:rPr /><a:t> </a:t></a:r><a:r><a:rPr /><a:t>avec</a:t></a:r><a:r><a:rPr /><a:t> </a:t></a:r><a:r><a:rPr /><a:t>la</a:t></a:r><a:r><a:rPr /><a:t> </a:t></a:r><a:r><a:rPr /><a:t>yupana</a:t></a:r><a:r><a:rPr /><a:t> </a:t></a:r><a:r><a:rPr /><a:t>inca</a:t></a:r></a:p></a:txBody></a:tc></a:tr><a:tr h="0"><a:tc><a:txBody><a:bodyPr /><a:lstStyle /><a:p><a:pPr lvl="0" marL="0" indent="0" algn="l"><a:buNone /></a:pPr><a:r><a:rPr /><a:t>Secondaire</a:t></a:r></a:p></a:txBody></a:tc><a:tc><a:txBody><a:bodyPr /><a:lstStyle /><a:p><a:pPr lvl="0" marL="0" indent="0" algn="l"><a:buNone /></a:pPr><a:r><a:rPr /><a:t>Géométrie</a:t></a:r><a:r><a:rPr /><a:t> </a:t></a:r><a:r><a:rPr /><a:t>avec</a:t></a:r><a:r><a:rPr /><a:t> </a:t></a:r><a:r><a:rPr /><a:t>l’impression</a:t></a:r><a:r><a:rPr /><a:t> </a:t></a:r><a:r><a:rPr /><a:t>3D</a:t></a:r></a:p></a:txBody></a:tc></a:tr><a:tr h="0"><a:tc><a:txBody><a:bodyPr /><a:lstStyle /><a:p><a:pPr lvl="0" marL="0" indent="0" algn="l"><a:buNone /></a:pPr><a:r><a:rPr /><a:t>Supérieur</a:t></a:r></a:p></a:txBody></a:tc><a:tc><a:txBody><a:bodyPr /><a:lstStyle /><a:p><a:pPr lvl="0" marL="0" indent="0" algn="l"><a:buNone /></a:pPr><a:r><a:rPr /><a:t>Le</a:t></a:r><a:r><a:rPr /><a:t> </a:t></a:r><a:r><a:rPr /><a:t>raisonnement</a:t></a:r><a:r><a:rPr /><a:t> </a:t></a:r><a:r><a:rPr /><a:t>mathématique</a:t></a:r><a:r><a:rPr /><a:t> </a:t></a:r><a:r><a:rPr /><a:t>avec</a:t></a:r><a:r><a:rPr /><a:t> </a:t></a:r><a:r><a:rPr /><a:t>L</a:t></a:r><a14:m><m:oMath xmlns:m="http://schemas.openxmlformats.org/officeDocument/2006/math"><m:r><m:t>∃</m:t></m:r><m:r><m:t>∀</m:t></m:r></m:oMath></a14:m><a:r><a:rPr /><a:t>N</a:t></a:r></a:p></a:txBody></a:tc></a:tr></a:tbl></a:graphicData></a:graphic></p:graphicFrame></p:spTree></p:cSld></p:sld>
-</file>
-
 <file path=ppt/slides/slide17.xml><?xml version="1.0" encoding="utf-8"?>
 <p:sld xmlns:a="http://schemas.openxmlformats.org/drawingml/2006/main" xmlns:r="http://schemas.openxmlformats.org/officeDocument/2006/relationships" xmlns:p="http://schemas.openxmlformats.org/presentationml/2006/main">
   <p:cSld>
@@ -4440,6 +4502,47 @@
       </p:grpSpPr>
       <p:sp>
         <p:nvSpPr>
+          <p:cNvPr id="2" name="Title 1"/>
+          <p:cNvSpPr>
+            <a:spLocks noGrp="1"/>
+          </p:cNvSpPr>
+          <p:nvPr>
+            <p:ph type="title"/>
+          </p:nvPr>
+        </p:nvSpPr>
+        <p:spPr/>
+        <p:txBody>
+          <a:bodyPr/>
+          <a:lstStyle/>
+          <a:p>
+            <a:pPr lvl="0" marL="0" indent="0">
+              <a:buNone/>
+            </a:pPr>
+            <a:r>
+              <a:rPr/>
+              <a:t>Propositions</a:t>
+            </a:r>
+            <a:r>
+              <a:rPr/>
+              <a:t> </a:t>
+            </a:r>
+            <a:r>
+              <a:rPr/>
+              <a:t>pour</a:t>
+            </a:r>
+            <a:r>
+              <a:rPr/>
+              <a:t> </a:t>
+            </a:r>
+            <a:r>
+              <a:rPr/>
+              <a:t>SFERE-Provence</a:t>
+            </a:r>
+          </a:p>
+        </p:txBody>
+      </p:sp>
+      <p:sp>
+        <p:nvSpPr>
           <p:cNvPr id="3" name="Content Placeholder 2"/>
           <p:cNvSpPr>
             <a:spLocks noGrp="1"/>
@@ -4454,11 +4557,23 @@
           <a:lstStyle/>
           <a:p>
             <a:pPr lvl="0" marL="0" indent="0">
+              <a:spcBef>
+                <a:spcPts val="3000"/>
+              </a:spcBef>
               <a:buNone/>
             </a:pPr>
             <a:r>
-              <a:rPr/>
-              <a:t>pourraient bénéficier d’une collaboration dans Sfere au délà de l’ADEF, par exemple avec l’I2M et l’IREM de Marseille.</a:t>
+              <a:rPr b="1"/>
+              <a:t>Projets de recherche</a:t>
+            </a:r>
+          </a:p>
+          <a:p>
+            <a:pPr lvl="0" marL="0" indent="0">
+              <a:buNone/>
+            </a:pPr>
+            <a:r>
+              <a:rPr/>
+              <a:t>Les projets de recherche déjà présentés:</a:t>
             </a:r>
           </a:p>
         </p:txBody>
@@ -4468,120 +4583,8 @@
 </p:sld>
 </file>
 
-<file path=ppt/slides/slide18.xml><?xml version="1.0" encoding="utf-8"?>
-<p:sld xmlns:a="http://schemas.openxmlformats.org/drawingml/2006/main" xmlns:r="http://schemas.openxmlformats.org/officeDocument/2006/relationships" xmlns:p="http://schemas.openxmlformats.org/presentationml/2006/main">
-  <p:cSld>
-    <p:spTree>
-      <p:nvGrpSpPr>
-        <p:cNvPr id="1" name=""/>
-        <p:cNvGrpSpPr/>
-        <p:nvPr/>
-      </p:nvGrpSpPr>
-      <p:grpSpPr>
-        <a:xfrm>
-          <a:off x="0" y="0"/>
-          <a:ext cx="0" cy="0"/>
-          <a:chOff x="0" y="0"/>
-          <a:chExt cx="0" cy="0"/>
-        </a:xfrm>
-      </p:grpSpPr>
-      <p:sp>
-        <p:nvSpPr>
-          <p:cNvPr id="3" name="Content Placeholder 2"/>
-          <p:cNvSpPr>
-            <a:spLocks noGrp="1"/>
-          </p:cNvSpPr>
-          <p:nvPr>
-            <p:ph idx="1"/>
-          </p:nvPr>
-        </p:nvSpPr>
-        <p:spPr/>
-        <p:txBody>
-          <a:bodyPr/>
-          <a:lstStyle/>
-          <a:p>
-            <a:pPr lvl="0" marL="0" indent="0">
-              <a:spcBef>
-                <a:spcPts val="3000"/>
-              </a:spcBef>
-              <a:buNone/>
-            </a:pPr>
-            <a:r>
-              <a:rPr b="1"/>
-              <a:t>Colloques et rencontres</a:t>
-            </a:r>
-          </a:p>
-          <a:p>
-            <a:pPr lvl="0" marL="0" indent="0">
-              <a:spcBef>
-                <a:spcPts val="3000"/>
-              </a:spcBef>
-              <a:buNone/>
-            </a:pPr>
-            <a:r>
-              <a:rPr b="1"/>
-              <a:t>Expérience</a:t>
-            </a:r>
-          </a:p>
-          <a:p>
-            <a:pPr lvl="0" marL="0" indent="0">
-              <a:buNone/>
-            </a:pPr>
-            <a:r>
-              <a:rPr/>
-              <a:t>2015: Médiation scientifique et plateformes de partage</a:t>
-            </a:r>
-            <a:br/>
-            <a:r>
-              <a:rPr/>
-              <a:t>2020: Outils logiciels pour les mathématiques et l’illustration</a:t>
-            </a:r>
-          </a:p>
-          <a:p>
-            <a:pPr lvl="0" marL="0" indent="0">
-              <a:spcBef>
-                <a:spcPts val="3000"/>
-              </a:spcBef>
-              <a:buNone/>
-            </a:pPr>
-            <a:r>
-              <a:rPr b="1"/>
-              <a:t>Propositions</a:t>
-            </a:r>
-          </a:p>
-          <a:p>
-            <a:pPr lvl="1"/>
-            <a:r>
-              <a:rPr/>
-              <a:t>Rencontre interrogeant la médiation, ses usages et ses effets</a:t>
-            </a:r>
-          </a:p>
-          <a:p>
-            <a:pPr lvl="2"/>
-            <a:r>
-              <a:rPr/>
-              <a:t>suite du projet 1.3. cartographie de la relation entre l’éducation, la médiation, les expériences artistique et scientifique et le développement de la personne, 2018</a:t>
-            </a:r>
-          </a:p>
-          <a:p>
-            <a:pPr lvl="1"/>
-            <a:r>
-              <a:rPr/>
-              <a:t>Ateliers Software Carpentry</a:t>
-            </a:r>
-          </a:p>
-          <a:p>
-            <a:pPr lvl="2"/>
-            <a:r>
-              <a:rPr/>
-              <a:t>formation à des compétences informatiques pour la recherche.</a:t>
-            </a:r>
-          </a:p>
-        </p:txBody>
-      </p:sp>
-    </p:spTree>
-  </p:cSld>
-</p:sld>
+<file path=ppt/slides/slide18.xml><?xml version="1.0" encoding="UTF-8"?>
+<p:sld xmlns:a="http://schemas.openxmlformats.org/drawingml/2006/main" xmlns:r="http://schemas.openxmlformats.org/officeDocument/2006/relationships" xmlns:p="http://schemas.openxmlformats.org/presentationml/2006/main"><p:cSld><p:spTree><p:nvGrpSpPr><p:cNvPr id="1" name="" /><p:cNvGrpSpPr /><p:nvPr /></p:nvGrpSpPr><p:grpSpPr><a:xfrm><a:off x="0" y="0" /><a:ext cx="0" cy="0" /><a:chOff x="0" y="0" /><a:chExt cx="0" cy="0" /></a:xfrm></p:grpSpPr><p:graphicFrame><p:nvGraphicFramePr><p:cNvPr id="6" name="Content Placeholder 5" /><p:cNvGraphicFramePr><a:graphicFrameLocks noGrp="1" /></p:cNvGraphicFramePr><p:nvPr><p:ph idx="1" /></p:nvPr></p:nvGraphicFramePr><p:xfrm><a:off x="457200" y="1600200" /><a:ext cx="8229600" cy="4521200" /></p:xfrm><a:graphic><a:graphicData uri="http://schemas.openxmlformats.org/drawingml/2006/table"><a:tbl><a:tblPr firstRow="1" bandRow="1"><a:tableStyleId>{5C22544A-7EE6-4342-B048-85BDC9FD1C3A}</a:tableStyleId></a:tblPr><a:tblGrid><a:gridCol w="4114800" /><a:gridCol w="4114800" /></a:tblGrid><a:tr h="0"><a:tc><a:txBody><a:bodyPr /><a:lstStyle /><a:p><a:pPr lvl="0" marL="0" indent="0" algn="l"><a:buNone /></a:pPr><a:r><a:rPr /><a:t>Primaire</a:t></a:r></a:p></a:txBody></a:tc><a:tc><a:txBody><a:bodyPr /><a:lstStyle /><a:p><a:pPr lvl="0" marL="0" indent="0" algn="l"><a:buNone /></a:pPr><a:r><a:rPr /><a:t>Nombres</a:t></a:r><a:r><a:rPr /><a:t> </a:t></a:r><a:r><a:rPr /><a:t>avec</a:t></a:r><a:r><a:rPr /><a:t> </a:t></a:r><a:r><a:rPr /><a:t>la</a:t></a:r><a:r><a:rPr /><a:t> </a:t></a:r><a:r><a:rPr /><a:t>yupana</a:t></a:r><a:r><a:rPr /><a:t> </a:t></a:r><a:r><a:rPr /><a:t>inca</a:t></a:r></a:p></a:txBody></a:tc></a:tr><a:tr h="0"><a:tc><a:txBody><a:bodyPr /><a:lstStyle /><a:p><a:pPr lvl="0" marL="0" indent="0" algn="l"><a:buNone /></a:pPr><a:r><a:rPr /><a:t>Secondaire</a:t></a:r></a:p></a:txBody></a:tc><a:tc><a:txBody><a:bodyPr /><a:lstStyle /><a:p><a:pPr lvl="0" marL="0" indent="0" algn="l"><a:buNone /></a:pPr><a:r><a:rPr /><a:t>Géométrie</a:t></a:r><a:r><a:rPr /><a:t> </a:t></a:r><a:r><a:rPr /><a:t>avec</a:t></a:r><a:r><a:rPr /><a:t> </a:t></a:r><a:r><a:rPr /><a:t>l’impression</a:t></a:r><a:r><a:rPr /><a:t> </a:t></a:r><a:r><a:rPr /><a:t>3D</a:t></a:r></a:p></a:txBody></a:tc></a:tr><a:tr h="0"><a:tc><a:txBody><a:bodyPr /><a:lstStyle /><a:p><a:pPr lvl="0" marL="0" indent="0" algn="l"><a:buNone /></a:pPr><a:r><a:rPr /><a:t>Supérieur</a:t></a:r></a:p></a:txBody></a:tc><a:tc><a:txBody><a:bodyPr /><a:lstStyle /><a:p><a:pPr lvl="0" marL="0" indent="0" algn="l"><a:buNone /></a:pPr><a:r><a:rPr /><a:t>Le</a:t></a:r><a:r><a:rPr /><a:t> </a:t></a:r><a:r><a:rPr /><a:t>raisonnement</a:t></a:r><a:r><a:rPr /><a:t> </a:t></a:r><a:r><a:rPr /><a:t>mathématique</a:t></a:r><a:r><a:rPr /><a:t> </a:t></a:r><a:r><a:rPr /><a:t>avec</a:t></a:r><a:r><a:rPr /><a:t> </a:t></a:r><a:r><a:rPr /><a:t>L</a:t></a:r><a14:m><m:oMath xmlns:m="http://schemas.openxmlformats.org/officeDocument/2006/math"><m:r><m:t>∃</m:t></m:r><m:r><m:t>∀</m:t></m:r></m:oMath></a14:m><a:r><a:rPr /><a:t>N</a:t></a:r></a:p></a:txBody></a:tc></a:tr></a:tbl></a:graphicData></a:graphic></p:graphicFrame></p:spTree></p:cSld></p:sld>
 </file>
 
 <file path=ppt/slides/slide19.xml><?xml version="1.0" encoding="utf-8"?>
@@ -4617,14 +4620,11 @@
           <a:lstStyle/>
           <a:p>
             <a:pPr lvl="0" marL="0" indent="0">
-              <a:spcBef>
-                <a:spcPts val="3000"/>
-              </a:spcBef>
               <a:buNone/>
             </a:pPr>
             <a:r>
-              <a:rPr b="1"/>
-              <a:t>Médiation scientifique</a:t>
+              <a:rPr/>
+              <a:t>pourraient bénéficier d’une collaboration dans Sfere au délà de l’ADEF, par exemple avec l’I2M et l’IREM de Marseille.</a:t>
             </a:r>
           </a:p>
         </p:txBody>
@@ -4723,6 +4723,172 @@
 </file>
 
 <file path=ppt/slides/slide20.xml><?xml version="1.0" encoding="utf-8"?>
+<p:sld xmlns:a="http://schemas.openxmlformats.org/drawingml/2006/main" xmlns:r="http://schemas.openxmlformats.org/officeDocument/2006/relationships" xmlns:p="http://schemas.openxmlformats.org/presentationml/2006/main">
+  <p:cSld>
+    <p:spTree>
+      <p:nvGrpSpPr>
+        <p:cNvPr id="1" name=""/>
+        <p:cNvGrpSpPr/>
+        <p:nvPr/>
+      </p:nvGrpSpPr>
+      <p:grpSpPr>
+        <a:xfrm>
+          <a:off x="0" y="0"/>
+          <a:ext cx="0" cy="0"/>
+          <a:chOff x="0" y="0"/>
+          <a:chExt cx="0" cy="0"/>
+        </a:xfrm>
+      </p:grpSpPr>
+      <p:sp>
+        <p:nvSpPr>
+          <p:cNvPr id="3" name="Content Placeholder 2"/>
+          <p:cNvSpPr>
+            <a:spLocks noGrp="1"/>
+          </p:cNvSpPr>
+          <p:nvPr>
+            <p:ph idx="1"/>
+          </p:nvPr>
+        </p:nvSpPr>
+        <p:spPr/>
+        <p:txBody>
+          <a:bodyPr/>
+          <a:lstStyle/>
+          <a:p>
+            <a:pPr lvl="0" marL="0" indent="0">
+              <a:spcBef>
+                <a:spcPts val="3000"/>
+              </a:spcBef>
+              <a:buNone/>
+            </a:pPr>
+            <a:r>
+              <a:rPr b="1"/>
+              <a:t>Colloques et rencontres</a:t>
+            </a:r>
+          </a:p>
+          <a:p>
+            <a:pPr lvl="0" marL="0" indent="0">
+              <a:spcBef>
+                <a:spcPts val="3000"/>
+              </a:spcBef>
+              <a:buNone/>
+            </a:pPr>
+            <a:r>
+              <a:rPr b="1"/>
+              <a:t>Expérience</a:t>
+            </a:r>
+          </a:p>
+          <a:p>
+            <a:pPr lvl="0" marL="0" indent="0">
+              <a:buNone/>
+            </a:pPr>
+            <a:r>
+              <a:rPr/>
+              <a:t>2015: Médiation scientifique et plateformes de partage</a:t>
+            </a:r>
+            <a:br/>
+            <a:r>
+              <a:rPr/>
+              <a:t>2020: Outils logiciels pour les mathématiques et l’illustration</a:t>
+            </a:r>
+          </a:p>
+          <a:p>
+            <a:pPr lvl="0" marL="0" indent="0">
+              <a:spcBef>
+                <a:spcPts val="3000"/>
+              </a:spcBef>
+              <a:buNone/>
+            </a:pPr>
+            <a:r>
+              <a:rPr b="1"/>
+              <a:t>Propositions</a:t>
+            </a:r>
+          </a:p>
+          <a:p>
+            <a:pPr lvl="1"/>
+            <a:r>
+              <a:rPr/>
+              <a:t>Rencontre interrogeant la médiation, ses usages et ses effets</a:t>
+            </a:r>
+          </a:p>
+          <a:p>
+            <a:pPr lvl="2"/>
+            <a:r>
+              <a:rPr/>
+              <a:t>suite du projet 1.3. cartographie de la relation entre l’éducation, la médiation, les expériences artistique et scientifique et le développement de la personne, 2018</a:t>
+            </a:r>
+          </a:p>
+          <a:p>
+            <a:pPr lvl="1"/>
+            <a:r>
+              <a:rPr/>
+              <a:t>Ateliers Software Carpentry</a:t>
+            </a:r>
+          </a:p>
+          <a:p>
+            <a:pPr lvl="2"/>
+            <a:r>
+              <a:rPr/>
+              <a:t>formation à des compétences informatiques pour la recherche.</a:t>
+            </a:r>
+          </a:p>
+        </p:txBody>
+      </p:sp>
+    </p:spTree>
+  </p:cSld>
+</p:sld>
+</file>
+
+<file path=ppt/slides/slide21.xml><?xml version="1.0" encoding="utf-8"?>
+<p:sld xmlns:a="http://schemas.openxmlformats.org/drawingml/2006/main" xmlns:r="http://schemas.openxmlformats.org/officeDocument/2006/relationships" xmlns:p="http://schemas.openxmlformats.org/presentationml/2006/main">
+  <p:cSld>
+    <p:spTree>
+      <p:nvGrpSpPr>
+        <p:cNvPr id="1" name=""/>
+        <p:cNvGrpSpPr/>
+        <p:nvPr/>
+      </p:nvGrpSpPr>
+      <p:grpSpPr>
+        <a:xfrm>
+          <a:off x="0" y="0"/>
+          <a:ext cx="0" cy="0"/>
+          <a:chOff x="0" y="0"/>
+          <a:chExt cx="0" cy="0"/>
+        </a:xfrm>
+      </p:grpSpPr>
+      <p:sp>
+        <p:nvSpPr>
+          <p:cNvPr id="3" name="Content Placeholder 2"/>
+          <p:cNvSpPr>
+            <a:spLocks noGrp="1"/>
+          </p:cNvSpPr>
+          <p:nvPr>
+            <p:ph idx="1"/>
+          </p:nvPr>
+        </p:nvSpPr>
+        <p:spPr/>
+        <p:txBody>
+          <a:bodyPr/>
+          <a:lstStyle/>
+          <a:p>
+            <a:pPr lvl="0" marL="0" indent="0">
+              <a:spcBef>
+                <a:spcPts val="3000"/>
+              </a:spcBef>
+              <a:buNone/>
+            </a:pPr>
+            <a:r>
+              <a:rPr b="1"/>
+              <a:t>Médiation scientifique</a:t>
+            </a:r>
+          </a:p>
+        </p:txBody>
+      </p:sp>
+    </p:spTree>
+  </p:cSld>
+</p:sld>
+</file>
+
+<file path=ppt/slides/slide22.xml><?xml version="1.0" encoding="utf-8"?>
 <p:sld xmlns:a="http://schemas.openxmlformats.org/drawingml/2006/main" xmlns:r="http://schemas.openxmlformats.org/officeDocument/2006/relationships" xmlns:p="http://schemas.openxmlformats.org/presentationml/2006/main">
   <p:cSld>
     <p:spTree>
@@ -4774,7 +4940,7 @@
 </p:sld>
 </file>
 
-<file path=ppt/slides/slide21.xml><?xml version="1.0" encoding="utf-8"?>
+<file path=ppt/slides/slide23.xml><?xml version="1.0" encoding="utf-8"?>
 <p:sld xmlns:a="http://schemas.openxmlformats.org/drawingml/2006/main" xmlns:r="http://schemas.openxmlformats.org/officeDocument/2006/relationships" xmlns:p="http://schemas.openxmlformats.org/presentationml/2006/main">
   <p:cSld>
     <p:spTree>
@@ -4826,7 +4992,7 @@
 </p:sld>
 </file>
 
-<file path=ppt/slides/slide22.xml><?xml version="1.0" encoding="utf-8"?>
+<file path=ppt/slides/slide24.xml><?xml version="1.0" encoding="utf-8"?>
 <p:sld xmlns:a="http://schemas.openxmlformats.org/drawingml/2006/main" xmlns:r="http://schemas.openxmlformats.org/officeDocument/2006/relationships" xmlns:p="http://schemas.openxmlformats.org/presentationml/2006/main">
   <p:cSld>
     <p:spTree>
@@ -5132,7 +5298,7 @@
 </p:sld>
 </file>
 
-<file path=ppt/slides/slide23.xml><?xml version="1.0" encoding="utf-8"?>
+<file path=ppt/slides/slide25.xml><?xml version="1.0" encoding="utf-8"?>
 <p:sld xmlns:a="http://schemas.openxmlformats.org/drawingml/2006/main" xmlns:r="http://schemas.openxmlformats.org/officeDocument/2006/relationships" xmlns:p="http://schemas.openxmlformats.org/presentationml/2006/main">
   <p:cSld>
     <p:spTree>
@@ -5179,7 +5345,7 @@
 </p:sld>
 </file>
 
-<file path=ppt/slides/slide24.xml><?xml version="1.0" encoding="utf-8"?>
+<file path=ppt/slides/slide26.xml><?xml version="1.0" encoding="utf-8"?>
 <p:sld xmlns:a="http://schemas.openxmlformats.org/drawingml/2006/main" xmlns:r="http://schemas.openxmlformats.org/officeDocument/2006/relationships" xmlns:p="http://schemas.openxmlformats.org/presentationml/2006/main">
   <p:cSld>
     <p:spTree>
@@ -5655,110 +5821,36 @@
           <a:chExt cx="0" cy="0"/>
         </a:xfrm>
       </p:grpSpPr>
-      <p:sp>
-        <p:nvSpPr>
-          <p:cNvPr id="2" name="Title 1"/>
-          <p:cNvSpPr>
-            <a:spLocks noGrp="1"/>
-          </p:cNvSpPr>
-          <p:nvPr>
-            <p:ph type="title"/>
-          </p:nvPr>
-        </p:nvSpPr>
-        <p:spPr/>
-        <p:txBody>
-          <a:bodyPr/>
-          <a:lstStyle/>
-          <a:p>
-            <a:pPr lvl="0" marL="0" indent="0">
-              <a:buNone/>
-            </a:pPr>
-            <a:r>
-              <a:rPr/>
-              <a:t>Intégration</a:t>
-            </a:r>
-            <a:r>
-              <a:rPr/>
-              <a:t> </a:t>
-            </a:r>
-            <a:r>
-              <a:rPr/>
-              <a:t>à</a:t>
-            </a:r>
-            <a:r>
-              <a:rPr/>
-              <a:t> </a:t>
-            </a:r>
-            <a:r>
-              <a:rPr/>
-              <a:t>l’Inspé</a:t>
-            </a:r>
-          </a:p>
-        </p:txBody>
-      </p:sp>
-      <p:sp>
-        <p:nvSpPr>
-          <p:cNvPr id="3" name="Content Placeholder 2"/>
-          <p:cNvSpPr>
-            <a:spLocks noGrp="1"/>
-          </p:cNvSpPr>
-          <p:nvPr>
-            <p:ph idx="1"/>
-          </p:nvPr>
-        </p:nvSpPr>
-        <p:spPr/>
-        <p:txBody>
-          <a:bodyPr/>
-          <a:lstStyle/>
-          <a:p>
-            <a:pPr lvl="0" marL="0" indent="0">
-              <a:spcBef>
-                <a:spcPts val="3000"/>
-              </a:spcBef>
-              <a:buNone/>
-            </a:pPr>
-            <a:r>
-              <a:rPr b="1"/>
-              <a:t>Motivée par les questions éducatives</a:t>
-            </a:r>
-          </a:p>
-          <a:p>
-            <a:pPr lvl="1"/>
-            <a:r>
-              <a:rPr/>
-              <a:t>suivi deux MOOC sur l’éducation</a:t>
-            </a:r>
-          </a:p>
-          <a:p>
-            <a:pPr lvl="2"/>
-            <a:r>
-              <a:rPr/>
-              <a:t>eFan Maths session 2 (ESPÉ de Lyon et autres partenaires)</a:t>
-            </a:r>
-          </a:p>
-          <a:p>
-            <a:pPr lvl="3"/>
-            <a:r>
-              <a:rPr/>
-              <a:t>projet «Objets mathématiques imprimés en 3D»</a:t>
-            </a:r>
-          </a:p>
-          <a:p>
-            <a:pPr lvl="2"/>
-            <a:r>
-              <a:rPr/>
-              <a:t>Design and Development of Educational Technology (MIT)</a:t>
-            </a:r>
-          </a:p>
-          <a:p>
-            <a:pPr lvl="3"/>
-            <a:r>
-              <a:rPr/>
-              <a:t>projet «Plagiarism prevention»</a:t>
-            </a:r>
-          </a:p>
-        </p:txBody>
-      </p:sp>
+      <p:pic>
+        <p:nvPicPr>
+          <p:cNvPr descr="img/dini-alba.png" id="0" name="Picture 1"/>
+          <p:cNvPicPr>
+            <a:picLocks noGrp="1" noChangeAspect="1"/>
+          </p:cNvPicPr>
+          <p:nvPr/>
+        </p:nvPicPr>
+        <p:blipFill>
+          <a:blip r:embed="rId2"/>
+          <a:stretch>
+            <a:fillRect/>
+          </a:stretch>
+        </p:blipFill>
+        <p:spPr bwMode="auto">
+          <a:xfrm>
+            <a:off x="939800" y="1600200"/>
+            <a:ext cx="7251700" cy="4521200"/>
+          </a:xfrm>
+          <a:prstGeom prst="rect">
+            <a:avLst/>
+          </a:prstGeom>
+          <a:noFill/>
+          <a:ln w="9525">
+            <a:noFill/>
+            <a:headEnd/>
+            <a:tailEnd/>
+          </a:ln>
+        </p:spPr>
+      </p:pic>
     </p:spTree>
   </p:cSld>
 </p:sld>

</xml_diff>